<commit_message>
Fix architecture deck arrows that PowerPoint refused to draw
Two diagonal connectors were written with negative widths, which
LibreOffice tolerates but PowerPoint treats as broken geometry.
Rewritten as positive extents with flipH - same rendered result,
valid everywhere.
</commit_message>
<xml_diff>
--- a/docs/BFF-Architecture-Overview.pptx
+++ b/docs/BFF-Architecture-Overview.pptx
@@ -3880,9 +3880,9 @@
           <p:nvPr/>
         </p:nvSpPr>
         <p:spPr>
-          <a:xfrm>
-            <a:off x="9052560" y="4297680"/>
-            <a:ext cx="-2194560" cy="685800"/>
+          <a:xfrm flipH="1">
+            <a:off x="6858000" y="4297680"/>
+            <a:ext cx="2194560" cy="685800"/>
           </a:xfrm>
           <a:prstGeom prst="line">
             <a:avLst/>
@@ -11319,9 +11319,9 @@
           <p:nvPr/>
         </p:nvSpPr>
         <p:spPr>
-          <a:xfrm>
-            <a:off x="8275320" y="3291840"/>
-            <a:ext cx="-1371600" cy="1463040"/>
+          <a:xfrm flipH="1">
+            <a:off x="6903720" y="3291840"/>
+            <a:ext cx="1371600" cy="1463040"/>
           </a:xfrm>
           <a:prstGeom prst="line">
             <a:avLst/>

</xml_diff>